<commit_message>
Chữ SAP to hơn: 28pt lên 36pt
Co-Authored-By: Claude Opus 5 <noreply@anthropic.com>
Claude-Session: https://claude.ai/code/session_011byrCkBWXeuJWCjrTMvtrk
</commit_message>
<xml_diff>
--- a/slide/DEFAULT_EXCLUDE_4PL_FOR_NEW_CUSTOMER_LOREAL.pptx
+++ b/slide/DEFAULT_EXCLUDE_4PL_FOR_NEW_CUSTOMER_LOREAL.pptx
@@ -15267,7 +15267,7 @@
         <p:spPr>
           <a:xfrm>
             <a:off x="630936" y="3520440"/>
-            <a:ext cx="2377440" cy="502920"/>
+            <a:ext cx="2377440" cy="640080"/>
           </a:xfrm>
           <a:prstGeom prst="rect">
             <a:avLst/>
@@ -15282,7 +15282,7 @@
           <a:p>
             <a:pPr algn="ctr"/>
             <a:r>
-              <a:rPr sz="2800" b="1">
+              <a:rPr sz="3600" b="1">
                 <a:solidFill>
                   <a:srgbClr val="FFFFFF"/>
                 </a:solidFill>

</xml_diff>